<commit_message>
Backend improvements: fix GROQ_MODEL default, add model endpoint, improve logging
- Fix GROQ_MODEL default from 'openai/gpt-oss-120b' to 'llama-3.3-70b-versatile' (correct Groq model)
- Add GROQ_MODEL config to environment
- Enhance root endpoint to include model info for frontend consumption
- Update frontend to fetch and display actual LLM model name dynamically
- Replace emoji logging with text-based [OK]/[ERROR] for better Windows compatibility
- Add helpful note about pinecone 7.x compatibility requirement

Co-authored-by: Copilot <223556219+Copilot@users.noreply.github.com>
</commit_message>
<xml_diff>
--- a/LegalRAG_Zeroth_Review.pptx
+++ b/LegalRAG_Zeroth_Review.pptx
@@ -5,7 +5,7 @@
     <p:sldMasterId id="2147483648" r:id="rId1"/>
   </p:sldMasterIdLst>
   <p:notesMasterIdLst>
-    <p:notesMasterId r:id="rId19"/>
+    <p:notesMasterId r:id="rId18"/>
   </p:notesMasterIdLst>
   <p:sldIdLst>
     <p:sldId id="256" r:id="rId2"/>
@@ -21,10 +21,9 @@
     <p:sldId id="267" r:id="rId12"/>
     <p:sldId id="268" r:id="rId13"/>
     <p:sldId id="269" r:id="rId14"/>
-    <p:sldId id="270" r:id="rId15"/>
-    <p:sldId id="271" r:id="rId16"/>
-    <p:sldId id="272" r:id="rId17"/>
-    <p:sldId id="273" r:id="rId18"/>
+    <p:sldId id="271" r:id="rId15"/>
+    <p:sldId id="272" r:id="rId16"/>
+    <p:sldId id="273" r:id="rId17"/>
   </p:sldIdLst>
   <p:sldSz cx="12192000" cy="6858000"/>
   <p:notesSz cx="6858000" cy="12192000"/>
@@ -907,90 +906,6 @@
             <a:fld id="{F7021451-1387-4CA6-816F-3879F97B5CBC}" type="slidenum">
               <a:rPr lang="en-US"/>
               <a:t>16</a:t>
-            </a:fld>
-            <a:endParaRPr lang="en-US"/>
-          </a:p>
-        </p:txBody>
-      </p:sp>
-    </p:spTree>
-    <p:extLst>
-      <p:ext uri="{BB962C8B-B14F-4D97-AF65-F5344CB8AC3E}">
-        <p14:creationId xmlns:p14="http://schemas.microsoft.com/office/powerpoint/2010/main" val="1024086991"/>
-      </p:ext>
-    </p:extLst>
-  </p:cSld>
-  <p:clrMapOvr>
-    <a:masterClrMapping/>
-  </p:clrMapOvr>
-</p:notes>
-</file>
-
-<file path=ppt/notesSlides/notesSlide17.xml><?xml version="1.0" encoding="utf-8"?>
-<p:notes xmlns:a="http://schemas.openxmlformats.org/drawingml/2006/main" xmlns:r="http://schemas.openxmlformats.org/officeDocument/2006/relationships" xmlns:p="http://schemas.openxmlformats.org/presentationml/2006/main">
-  <p:cSld>
-    <p:spTree>
-      <p:nvGrpSpPr>
-        <p:cNvPr id="1" name=""/>
-        <p:cNvGrpSpPr/>
-        <p:nvPr/>
-      </p:nvGrpSpPr>
-      <p:grpSpPr>
-        <a:xfrm>
-          <a:off x="0" y="0"/>
-          <a:ext cx="0" cy="0"/>
-          <a:chOff x="0" y="0"/>
-          <a:chExt cx="0" cy="0"/>
-        </a:xfrm>
-      </p:grpSpPr>
-      <p:sp>
-        <p:nvSpPr>
-          <p:cNvPr id="2" name="Slide Image Placeholder 1"/>
-          <p:cNvSpPr>
-            <a:spLocks noGrp="1" noRot="1" noChangeAspect="1"/>
-          </p:cNvSpPr>
-          <p:nvPr>
-            <p:ph type="sldImg"/>
-          </p:nvPr>
-        </p:nvSpPr>
-        <p:spPr/>
-      </p:sp>
-      <p:sp>
-        <p:nvSpPr>
-          <p:cNvPr id="3" name="Notes Placeholder 2"/>
-          <p:cNvSpPr>
-            <a:spLocks noGrp="1"/>
-          </p:cNvSpPr>
-          <p:nvPr>
-            <p:ph type="body" idx="1"/>
-          </p:nvPr>
-        </p:nvSpPr>
-        <p:spPr/>
-        <p:txBody>
-          <a:bodyPr/>
-          <a:lstStyle/>
-          <a:p>
-            <a:endParaRPr lang="en-US" dirty="0"/>
-          </a:p>
-        </p:txBody>
-      </p:sp>
-      <p:sp>
-        <p:nvSpPr>
-          <p:cNvPr id="4" name="Slide Number Placeholder 3"/>
-          <p:cNvSpPr>
-            <a:spLocks noGrp="1"/>
-          </p:cNvSpPr>
-          <p:nvPr>
-            <p:ph type="sldNum" sz="quarter" idx="10"/>
-          </p:nvPr>
-        </p:nvSpPr>
-        <p:spPr/>
-        <p:txBody>
-          <a:bodyPr/>
-          <a:lstStyle/>
-          <a:p>
-            <a:fld id="{F7021451-1387-4CA6-816F-3879F97B5CBC}" type="slidenum">
-              <a:rPr lang="en-US"/>
-              <a:t>17</a:t>
             </a:fld>
             <a:endParaRPr lang="en-US"/>
           </a:p>
@@ -2186,7 +2101,7 @@
               <a:buNone/>
             </a:pPr>
             <a:r>
-              <a:rPr lang="en-US" sz="6000" b="1" dirty="0">
+              <a:rPr lang="en-US" sz="6000" b="1" dirty="0" err="1">
                 <a:solidFill>
                   <a:srgbClr val="FFFFFF"/>
                 </a:solidFill>
@@ -2194,7 +2109,7 @@
                 <a:ea typeface="Cambria" pitchFamily="34" charset="-122"/>
                 <a:cs typeface="Cambria" pitchFamily="34" charset="-120"/>
               </a:rPr>
-              <a:t>LegalRAG</a:t>
+              <a:t>JuriScope</a:t>
             </a:r>
             <a:endParaRPr lang="en-US" sz="6000" dirty="0"/>
           </a:p>
@@ -8814,979 +8729,6 @@
 
 <file path=ppt/slides/slide14.xml><?xml version="1.0" encoding="utf-8"?>
 <p:sld xmlns:a="http://schemas.openxmlformats.org/drawingml/2006/main" xmlns:r="http://schemas.openxmlformats.org/officeDocument/2006/relationships" xmlns:p="http://schemas.openxmlformats.org/presentationml/2006/main">
-  <p:cSld name="Slide 15">
-    <p:bg>
-      <p:bgPr>
-        <a:solidFill>
-          <a:srgbClr val="F5F6F8"/>
-        </a:solidFill>
-        <a:effectLst/>
-      </p:bgPr>
-    </p:bg>
-    <p:spTree>
-      <p:nvGrpSpPr>
-        <p:cNvPr id="1" name=""/>
-        <p:cNvGrpSpPr/>
-        <p:nvPr/>
-      </p:nvGrpSpPr>
-      <p:grpSpPr>
-        <a:xfrm>
-          <a:off x="0" y="0"/>
-          <a:ext cx="0" cy="0"/>
-          <a:chOff x="0" y="0"/>
-          <a:chExt cx="0" cy="0"/>
-        </a:xfrm>
-      </p:grpSpPr>
-      <p:sp>
-        <p:nvSpPr>
-          <p:cNvPr id="2" name="Text 0"/>
-          <p:cNvSpPr/>
-          <p:nvPr/>
-        </p:nvSpPr>
-        <p:spPr>
-          <a:xfrm>
-            <a:off x="548640" y="320040"/>
-            <a:ext cx="7315200" cy="274320"/>
-          </a:xfrm>
-          <a:prstGeom prst="rect">
-            <a:avLst/>
-          </a:prstGeom>
-          <a:noFill/>
-          <a:ln/>
-        </p:spPr>
-        <p:txBody>
-          <a:bodyPr wrap="square" rtlCol="0" anchor="ctr"/>
-          <a:lstStyle/>
-          <a:p>
-            <a:pPr marL="0" indent="0">
-              <a:buNone/>
-            </a:pPr>
-            <a:r>
-              <a:rPr lang="en-US" sz="1200" b="1" kern="0" spc="200" dirty="0">
-                <a:solidFill>
-                  <a:srgbClr val="C9A24B"/>
-                </a:solidFill>
-                <a:latin typeface="Calibri" pitchFamily="34" charset="0"/>
-                <a:ea typeface="Calibri" pitchFamily="34" charset="-122"/>
-                <a:cs typeface="Calibri" pitchFamily="34" charset="-120"/>
-              </a:rPr>
-              <a:t>WALKTHROUGH</a:t>
-            </a:r>
-            <a:endParaRPr lang="en-US" sz="1200" dirty="0"/>
-          </a:p>
-        </p:txBody>
-      </p:sp>
-      <p:sp>
-        <p:nvSpPr>
-          <p:cNvPr id="3" name="Text 1"/>
-          <p:cNvSpPr/>
-          <p:nvPr/>
-        </p:nvSpPr>
-        <p:spPr>
-          <a:xfrm>
-            <a:off x="548640" y="566928"/>
-            <a:ext cx="10789920" cy="640080"/>
-          </a:xfrm>
-          <a:prstGeom prst="rect">
-            <a:avLst/>
-          </a:prstGeom>
-          <a:noFill/>
-          <a:ln/>
-        </p:spPr>
-        <p:txBody>
-          <a:bodyPr wrap="square" rtlCol="0" anchor="ctr"/>
-          <a:lstStyle/>
-          <a:p>
-            <a:pPr marL="0" indent="0">
-              <a:buNone/>
-            </a:pPr>
-            <a:r>
-              <a:rPr lang="en-US" sz="3000" b="1" dirty="0">
-                <a:solidFill>
-                  <a:srgbClr val="152238"/>
-                </a:solidFill>
-                <a:latin typeface="Cambria" pitchFamily="34" charset="0"/>
-                <a:ea typeface="Cambria" pitchFamily="34" charset="-122"/>
-                <a:cs typeface="Cambria" pitchFamily="34" charset="-120"/>
-              </a:rPr>
-              <a:t>Live Demo — Screens to Capture</a:t>
-            </a:r>
-            <a:endParaRPr lang="en-US" sz="3000" dirty="0"/>
-          </a:p>
-        </p:txBody>
-      </p:sp>
-      <p:sp>
-        <p:nvSpPr>
-          <p:cNvPr id="4" name="Text 2"/>
-          <p:cNvSpPr/>
-          <p:nvPr/>
-        </p:nvSpPr>
-        <p:spPr>
-          <a:xfrm>
-            <a:off x="548640" y="1234440"/>
-            <a:ext cx="10058400" cy="320040"/>
-          </a:xfrm>
-          <a:prstGeom prst="rect">
-            <a:avLst/>
-          </a:prstGeom>
-          <a:noFill/>
-          <a:ln/>
-        </p:spPr>
-        <p:txBody>
-          <a:bodyPr wrap="square" rtlCol="0" anchor="ctr"/>
-          <a:lstStyle/>
-          <a:p>
-            <a:pPr marL="0" indent="0">
-              <a:buNone/>
-            </a:pPr>
-            <a:r>
-              <a:rPr lang="en-US" sz="1300" i="1" dirty="0">
-                <a:solidFill>
-                  <a:srgbClr val="5B6B7F"/>
-                </a:solidFill>
-                <a:latin typeface="Calibri" pitchFamily="34" charset="0"/>
-                <a:ea typeface="Calibri" pitchFamily="34" charset="-122"/>
-                <a:cs typeface="Calibri" pitchFamily="34" charset="-120"/>
-              </a:rPr>
-              <a:t>Slide to be completed with live screenshots before presenting</a:t>
-            </a:r>
-            <a:endParaRPr lang="en-US" sz="1300" dirty="0"/>
-          </a:p>
-        </p:txBody>
-      </p:sp>
-      <p:sp>
-        <p:nvSpPr>
-          <p:cNvPr id="5" name="Shape 3"/>
-          <p:cNvSpPr/>
-          <p:nvPr/>
-        </p:nvSpPr>
-        <p:spPr>
-          <a:xfrm>
-            <a:off x="548640" y="1737360"/>
-            <a:ext cx="3520440" cy="1965960"/>
-          </a:xfrm>
-          <a:prstGeom prst="roundRect">
-            <a:avLst>
-              <a:gd name="adj" fmla="val 3721"/>
-            </a:avLst>
-          </a:prstGeom>
-          <a:solidFill>
-            <a:srgbClr val="FFFFFF"/>
-          </a:solidFill>
-          <a:ln w="15875">
-            <a:solidFill>
-              <a:srgbClr val="4C6A8A"/>
-            </a:solidFill>
-            <a:prstDash val="dash"/>
-          </a:ln>
-        </p:spPr>
-      </p:sp>
-      <p:sp>
-        <p:nvSpPr>
-          <p:cNvPr id="6" name="Shape 4"/>
-          <p:cNvSpPr/>
-          <p:nvPr/>
-        </p:nvSpPr>
-        <p:spPr>
-          <a:xfrm>
-            <a:off x="2034540" y="2057400"/>
-            <a:ext cx="548640" cy="548640"/>
-          </a:xfrm>
-          <a:prstGeom prst="ellipse">
-            <a:avLst/>
-          </a:prstGeom>
-          <a:solidFill>
-            <a:srgbClr val="E4E9F1"/>
-          </a:solidFill>
-          <a:ln/>
-        </p:spPr>
-      </p:sp>
-      <p:pic>
-        <p:nvPicPr>
-          <p:cNvPr id="7" name="Image 0" descr="/home/claude/legalrag_ppt/icons/file.png"/>
-          <p:cNvPicPr>
-            <a:picLocks noChangeAspect="1"/>
-          </p:cNvPicPr>
-          <p:nvPr/>
-        </p:nvPicPr>
-        <p:blipFill>
-          <a:blip r:embed="rId3"/>
-          <a:stretch>
-            <a:fillRect/>
-          </a:stretch>
-        </p:blipFill>
-        <p:spPr>
-          <a:xfrm>
-            <a:off x="2105863" y="2128723"/>
-            <a:ext cx="405994" cy="405994"/>
-          </a:xfrm>
-          <a:prstGeom prst="rect">
-            <a:avLst/>
-          </a:prstGeom>
-        </p:spPr>
-      </p:pic>
-      <p:sp>
-        <p:nvSpPr>
-          <p:cNvPr id="8" name="Text 5"/>
-          <p:cNvSpPr/>
-          <p:nvPr/>
-        </p:nvSpPr>
-        <p:spPr>
-          <a:xfrm>
-            <a:off x="685800" y="2743200"/>
-            <a:ext cx="3246120" cy="256032"/>
-          </a:xfrm>
-          <a:prstGeom prst="rect">
-            <a:avLst/>
-          </a:prstGeom>
-          <a:noFill/>
-          <a:ln/>
-        </p:spPr>
-        <p:txBody>
-          <a:bodyPr wrap="square" lIns="0" tIns="0" rIns="0" bIns="0" rtlCol="0" anchor="ctr"/>
-          <a:lstStyle/>
-          <a:p>
-            <a:pPr marL="0" indent="0" algn="ctr">
-              <a:buNone/>
-            </a:pPr>
-            <a:r>
-              <a:rPr lang="en-US" sz="1150" b="1" dirty="0">
-                <a:solidFill>
-                  <a:srgbClr val="4C6A8A"/>
-                </a:solidFill>
-                <a:latin typeface="Calibri" pitchFamily="34" charset="0"/>
-                <a:ea typeface="Calibri" pitchFamily="34" charset="-122"/>
-                <a:cs typeface="Calibri" pitchFamily="34" charset="-120"/>
-              </a:rPr>
-              <a:t>Screenshot 1</a:t>
-            </a:r>
-            <a:endParaRPr lang="en-US" sz="1150" dirty="0"/>
-          </a:p>
-        </p:txBody>
-      </p:sp>
-      <p:sp>
-        <p:nvSpPr>
-          <p:cNvPr id="9" name="Text 6"/>
-          <p:cNvSpPr/>
-          <p:nvPr/>
-        </p:nvSpPr>
-        <p:spPr>
-          <a:xfrm>
-            <a:off x="731520" y="3017520"/>
-            <a:ext cx="3154680" cy="594360"/>
-          </a:xfrm>
-          <a:prstGeom prst="rect">
-            <a:avLst/>
-          </a:prstGeom>
-          <a:noFill/>
-          <a:ln/>
-        </p:spPr>
-        <p:txBody>
-          <a:bodyPr wrap="square" lIns="0" tIns="0" rIns="0" bIns="0" rtlCol="0" anchor="t"/>
-          <a:lstStyle/>
-          <a:p>
-            <a:pPr marL="0" indent="0" algn="ctr">
-              <a:buNone/>
-            </a:pPr>
-            <a:r>
-              <a:rPr lang="en-US" sz="1000" dirty="0">
-                <a:solidFill>
-                  <a:srgbClr val="5B6B7F"/>
-                </a:solidFill>
-                <a:latin typeface="Calibri" pitchFamily="34" charset="0"/>
-                <a:ea typeface="Calibri" pitchFamily="34" charset="-122"/>
-                <a:cs typeface="Calibri" pitchFamily="34" charset="-120"/>
-              </a:rPr>
-              <a:t>Home screen with sample questions</a:t>
-            </a:r>
-            <a:endParaRPr lang="en-US" sz="1000" dirty="0"/>
-          </a:p>
-        </p:txBody>
-      </p:sp>
-      <p:sp>
-        <p:nvSpPr>
-          <p:cNvPr id="10" name="Shape 7"/>
-          <p:cNvSpPr/>
-          <p:nvPr/>
-        </p:nvSpPr>
-        <p:spPr>
-          <a:xfrm>
-            <a:off x="4297680" y="1737360"/>
-            <a:ext cx="3520440" cy="1965960"/>
-          </a:xfrm>
-          <a:prstGeom prst="roundRect">
-            <a:avLst>
-              <a:gd name="adj" fmla="val 3721"/>
-            </a:avLst>
-          </a:prstGeom>
-          <a:solidFill>
-            <a:srgbClr val="FFFFFF"/>
-          </a:solidFill>
-          <a:ln w="15875">
-            <a:solidFill>
-              <a:srgbClr val="4C6A8A"/>
-            </a:solidFill>
-            <a:prstDash val="dash"/>
-          </a:ln>
-        </p:spPr>
-      </p:sp>
-      <p:sp>
-        <p:nvSpPr>
-          <p:cNvPr id="11" name="Shape 8"/>
-          <p:cNvSpPr/>
-          <p:nvPr/>
-        </p:nvSpPr>
-        <p:spPr>
-          <a:xfrm>
-            <a:off x="5783580" y="2057400"/>
-            <a:ext cx="548640" cy="548640"/>
-          </a:xfrm>
-          <a:prstGeom prst="ellipse">
-            <a:avLst/>
-          </a:prstGeom>
-          <a:solidFill>
-            <a:srgbClr val="E4E9F1"/>
-          </a:solidFill>
-          <a:ln/>
-        </p:spPr>
-      </p:sp>
-      <p:pic>
-        <p:nvPicPr>
-          <p:cNvPr id="12" name="Image 1" descr="/home/claude/legalrag_ppt/icons/file.png"/>
-          <p:cNvPicPr>
-            <a:picLocks noChangeAspect="1"/>
-          </p:cNvPicPr>
-          <p:nvPr/>
-        </p:nvPicPr>
-        <p:blipFill>
-          <a:blip r:embed="rId3"/>
-          <a:stretch>
-            <a:fillRect/>
-          </a:stretch>
-        </p:blipFill>
-        <p:spPr>
-          <a:xfrm>
-            <a:off x="5854903" y="2128723"/>
-            <a:ext cx="405994" cy="405994"/>
-          </a:xfrm>
-          <a:prstGeom prst="rect">
-            <a:avLst/>
-          </a:prstGeom>
-        </p:spPr>
-      </p:pic>
-      <p:sp>
-        <p:nvSpPr>
-          <p:cNvPr id="13" name="Text 9"/>
-          <p:cNvSpPr/>
-          <p:nvPr/>
-        </p:nvSpPr>
-        <p:spPr>
-          <a:xfrm>
-            <a:off x="4434840" y="2743200"/>
-            <a:ext cx="3246120" cy="256032"/>
-          </a:xfrm>
-          <a:prstGeom prst="rect">
-            <a:avLst/>
-          </a:prstGeom>
-          <a:noFill/>
-          <a:ln/>
-        </p:spPr>
-        <p:txBody>
-          <a:bodyPr wrap="square" lIns="0" tIns="0" rIns="0" bIns="0" rtlCol="0" anchor="ctr"/>
-          <a:lstStyle/>
-          <a:p>
-            <a:pPr marL="0" indent="0" algn="ctr">
-              <a:buNone/>
-            </a:pPr>
-            <a:r>
-              <a:rPr lang="en-US" sz="1150" b="1" dirty="0">
-                <a:solidFill>
-                  <a:srgbClr val="4C6A8A"/>
-                </a:solidFill>
-                <a:latin typeface="Calibri" pitchFamily="34" charset="0"/>
-                <a:ea typeface="Calibri" pitchFamily="34" charset="-122"/>
-                <a:cs typeface="Calibri" pitchFamily="34" charset="-120"/>
-              </a:rPr>
-              <a:t>Screenshot 2</a:t>
-            </a:r>
-            <a:endParaRPr lang="en-US" sz="1150" dirty="0"/>
-          </a:p>
-        </p:txBody>
-      </p:sp>
-      <p:sp>
-        <p:nvSpPr>
-          <p:cNvPr id="14" name="Text 10"/>
-          <p:cNvSpPr/>
-          <p:nvPr/>
-        </p:nvSpPr>
-        <p:spPr>
-          <a:xfrm>
-            <a:off x="4480560" y="3017520"/>
-            <a:ext cx="3154680" cy="594360"/>
-          </a:xfrm>
-          <a:prstGeom prst="rect">
-            <a:avLst/>
-          </a:prstGeom>
-          <a:noFill/>
-          <a:ln/>
-        </p:spPr>
-        <p:txBody>
-          <a:bodyPr wrap="square" lIns="0" tIns="0" rIns="0" bIns="0" rtlCol="0" anchor="t"/>
-          <a:lstStyle/>
-          <a:p>
-            <a:pPr marL="0" indent="0" algn="ctr">
-              <a:buNone/>
-            </a:pPr>
-            <a:r>
-              <a:rPr lang="en-US" sz="1000" dirty="0">
-                <a:solidFill>
-                  <a:srgbClr val="5B6B7F"/>
-                </a:solidFill>
-                <a:latin typeface="Calibri" pitchFamily="34" charset="0"/>
-                <a:ea typeface="Calibri" pitchFamily="34" charset="-122"/>
-                <a:cs typeface="Calibri" pitchFamily="34" charset="-120"/>
-              </a:rPr>
-              <a:t>Uploading 2024072220.pdf (Rajnesh vs Neha)</a:t>
-            </a:r>
-            <a:endParaRPr lang="en-US" sz="1000" dirty="0"/>
-          </a:p>
-        </p:txBody>
-      </p:sp>
-      <p:sp>
-        <p:nvSpPr>
-          <p:cNvPr id="15" name="Shape 11"/>
-          <p:cNvSpPr/>
-          <p:nvPr/>
-        </p:nvSpPr>
-        <p:spPr>
-          <a:xfrm>
-            <a:off x="8046720" y="1737360"/>
-            <a:ext cx="3520440" cy="1965960"/>
-          </a:xfrm>
-          <a:prstGeom prst="roundRect">
-            <a:avLst>
-              <a:gd name="adj" fmla="val 3721"/>
-            </a:avLst>
-          </a:prstGeom>
-          <a:solidFill>
-            <a:srgbClr val="FFFFFF"/>
-          </a:solidFill>
-          <a:ln w="15875">
-            <a:solidFill>
-              <a:srgbClr val="4C6A8A"/>
-            </a:solidFill>
-            <a:prstDash val="dash"/>
-          </a:ln>
-        </p:spPr>
-      </p:sp>
-      <p:sp>
-        <p:nvSpPr>
-          <p:cNvPr id="16" name="Shape 12"/>
-          <p:cNvSpPr/>
-          <p:nvPr/>
-        </p:nvSpPr>
-        <p:spPr>
-          <a:xfrm>
-            <a:off x="9532620" y="2057400"/>
-            <a:ext cx="548640" cy="548640"/>
-          </a:xfrm>
-          <a:prstGeom prst="ellipse">
-            <a:avLst/>
-          </a:prstGeom>
-          <a:solidFill>
-            <a:srgbClr val="E4E9F1"/>
-          </a:solidFill>
-          <a:ln/>
-        </p:spPr>
-      </p:sp>
-      <p:pic>
-        <p:nvPicPr>
-          <p:cNvPr id="17" name="Image 2" descr="/home/claude/legalrag_ppt/icons/file.png"/>
-          <p:cNvPicPr>
-            <a:picLocks noChangeAspect="1"/>
-          </p:cNvPicPr>
-          <p:nvPr/>
-        </p:nvPicPr>
-        <p:blipFill>
-          <a:blip r:embed="rId3"/>
-          <a:stretch>
-            <a:fillRect/>
-          </a:stretch>
-        </p:blipFill>
-        <p:spPr>
-          <a:xfrm>
-            <a:off x="9603943" y="2128723"/>
-            <a:ext cx="405994" cy="405994"/>
-          </a:xfrm>
-          <a:prstGeom prst="rect">
-            <a:avLst/>
-          </a:prstGeom>
-        </p:spPr>
-      </p:pic>
-      <p:sp>
-        <p:nvSpPr>
-          <p:cNvPr id="18" name="Text 13"/>
-          <p:cNvSpPr/>
-          <p:nvPr/>
-        </p:nvSpPr>
-        <p:spPr>
-          <a:xfrm>
-            <a:off x="8183880" y="2743200"/>
-            <a:ext cx="3246120" cy="256032"/>
-          </a:xfrm>
-          <a:prstGeom prst="rect">
-            <a:avLst/>
-          </a:prstGeom>
-          <a:noFill/>
-          <a:ln/>
-        </p:spPr>
-        <p:txBody>
-          <a:bodyPr wrap="square" lIns="0" tIns="0" rIns="0" bIns="0" rtlCol="0" anchor="ctr"/>
-          <a:lstStyle/>
-          <a:p>
-            <a:pPr marL="0" indent="0" algn="ctr">
-              <a:buNone/>
-            </a:pPr>
-            <a:r>
-              <a:rPr lang="en-US" sz="1150" b="1" dirty="0">
-                <a:solidFill>
-                  <a:srgbClr val="4C6A8A"/>
-                </a:solidFill>
-                <a:latin typeface="Calibri" pitchFamily="34" charset="0"/>
-                <a:ea typeface="Calibri" pitchFamily="34" charset="-122"/>
-                <a:cs typeface="Calibri" pitchFamily="34" charset="-120"/>
-              </a:rPr>
-              <a:t>Screenshot 3</a:t>
-            </a:r>
-            <a:endParaRPr lang="en-US" sz="1150" dirty="0"/>
-          </a:p>
-        </p:txBody>
-      </p:sp>
-      <p:sp>
-        <p:nvSpPr>
-          <p:cNvPr id="19" name="Text 14"/>
-          <p:cNvSpPr/>
-          <p:nvPr/>
-        </p:nvSpPr>
-        <p:spPr>
-          <a:xfrm>
-            <a:off x="8229600" y="3017520"/>
-            <a:ext cx="3154680" cy="594360"/>
-          </a:xfrm>
-          <a:prstGeom prst="rect">
-            <a:avLst/>
-          </a:prstGeom>
-          <a:noFill/>
-          <a:ln/>
-        </p:spPr>
-        <p:txBody>
-          <a:bodyPr wrap="square" lIns="0" tIns="0" rIns="0" bIns="0" rtlCol="0" anchor="t"/>
-          <a:lstStyle/>
-          <a:p>
-            <a:pPr marL="0" indent="0" algn="ctr">
-              <a:buNone/>
-            </a:pPr>
-            <a:r>
-              <a:rPr lang="en-US" sz="1000" dirty="0">
-                <a:solidFill>
-                  <a:srgbClr val="5B6B7F"/>
-                </a:solidFill>
-                <a:latin typeface="Calibri" pitchFamily="34" charset="0"/>
-                <a:ea typeface="Calibri" pitchFamily="34" charset="-122"/>
-                <a:cs typeface="Calibri" pitchFamily="34" charset="-120"/>
-              </a:rPr>
-              <a:t>Q: “Who are the parties and what maintenance was awarded?”</a:t>
-            </a:r>
-            <a:endParaRPr lang="en-US" sz="1000" dirty="0"/>
-          </a:p>
-        </p:txBody>
-      </p:sp>
-      <p:sp>
-        <p:nvSpPr>
-          <p:cNvPr id="20" name="Shape 15"/>
-          <p:cNvSpPr/>
-          <p:nvPr/>
-        </p:nvSpPr>
-        <p:spPr>
-          <a:xfrm>
-            <a:off x="2537460" y="4023360"/>
-            <a:ext cx="3520440" cy="1965960"/>
-          </a:xfrm>
-          <a:prstGeom prst="roundRect">
-            <a:avLst>
-              <a:gd name="adj" fmla="val 3721"/>
-            </a:avLst>
-          </a:prstGeom>
-          <a:solidFill>
-            <a:srgbClr val="FFFFFF"/>
-          </a:solidFill>
-          <a:ln w="15875">
-            <a:solidFill>
-              <a:srgbClr val="4C6A8A"/>
-            </a:solidFill>
-            <a:prstDash val="dash"/>
-          </a:ln>
-        </p:spPr>
-      </p:sp>
-      <p:sp>
-        <p:nvSpPr>
-          <p:cNvPr id="21" name="Shape 16"/>
-          <p:cNvSpPr/>
-          <p:nvPr/>
-        </p:nvSpPr>
-        <p:spPr>
-          <a:xfrm>
-            <a:off x="4023360" y="4343400"/>
-            <a:ext cx="548640" cy="548640"/>
-          </a:xfrm>
-          <a:prstGeom prst="ellipse">
-            <a:avLst/>
-          </a:prstGeom>
-          <a:solidFill>
-            <a:srgbClr val="E4E9F1"/>
-          </a:solidFill>
-          <a:ln/>
-        </p:spPr>
-      </p:sp>
-      <p:pic>
-        <p:nvPicPr>
-          <p:cNvPr id="22" name="Image 3" descr="/home/claude/legalrag_ppt/icons/file.png"/>
-          <p:cNvPicPr>
-            <a:picLocks noChangeAspect="1"/>
-          </p:cNvPicPr>
-          <p:nvPr/>
-        </p:nvPicPr>
-        <p:blipFill>
-          <a:blip r:embed="rId3"/>
-          <a:stretch>
-            <a:fillRect/>
-          </a:stretch>
-        </p:blipFill>
-        <p:spPr>
-          <a:xfrm>
-            <a:off x="4094683" y="4414723"/>
-            <a:ext cx="405994" cy="405994"/>
-          </a:xfrm>
-          <a:prstGeom prst="rect">
-            <a:avLst/>
-          </a:prstGeom>
-        </p:spPr>
-      </p:pic>
-      <p:sp>
-        <p:nvSpPr>
-          <p:cNvPr id="23" name="Text 17"/>
-          <p:cNvSpPr/>
-          <p:nvPr/>
-        </p:nvSpPr>
-        <p:spPr>
-          <a:xfrm>
-            <a:off x="2674620" y="5029200"/>
-            <a:ext cx="3246120" cy="256032"/>
-          </a:xfrm>
-          <a:prstGeom prst="rect">
-            <a:avLst/>
-          </a:prstGeom>
-          <a:noFill/>
-          <a:ln/>
-        </p:spPr>
-        <p:txBody>
-          <a:bodyPr wrap="square" lIns="0" tIns="0" rIns="0" bIns="0" rtlCol="0" anchor="ctr"/>
-          <a:lstStyle/>
-          <a:p>
-            <a:pPr marL="0" indent="0" algn="ctr">
-              <a:buNone/>
-            </a:pPr>
-            <a:r>
-              <a:rPr lang="en-US" sz="1150" b="1" dirty="0">
-                <a:solidFill>
-                  <a:srgbClr val="4C6A8A"/>
-                </a:solidFill>
-                <a:latin typeface="Calibri" pitchFamily="34" charset="0"/>
-                <a:ea typeface="Calibri" pitchFamily="34" charset="-122"/>
-                <a:cs typeface="Calibri" pitchFamily="34" charset="-120"/>
-              </a:rPr>
-              <a:t>Screenshot 4</a:t>
-            </a:r>
-            <a:endParaRPr lang="en-US" sz="1150" dirty="0"/>
-          </a:p>
-        </p:txBody>
-      </p:sp>
-      <p:sp>
-        <p:nvSpPr>
-          <p:cNvPr id="24" name="Text 18"/>
-          <p:cNvSpPr/>
-          <p:nvPr/>
-        </p:nvSpPr>
-        <p:spPr>
-          <a:xfrm>
-            <a:off x="2720340" y="5303520"/>
-            <a:ext cx="3154680" cy="594360"/>
-          </a:xfrm>
-          <a:prstGeom prst="rect">
-            <a:avLst/>
-          </a:prstGeom>
-          <a:noFill/>
-          <a:ln/>
-        </p:spPr>
-        <p:txBody>
-          <a:bodyPr wrap="square" lIns="0" tIns="0" rIns="0" bIns="0" rtlCol="0" anchor="t"/>
-          <a:lstStyle/>
-          <a:p>
-            <a:pPr marL="0" indent="0" algn="ctr">
-              <a:buNone/>
-            </a:pPr>
-            <a:r>
-              <a:rPr lang="en-US" sz="1000" dirty="0">
-                <a:solidFill>
-                  <a:srgbClr val="5B6B7F"/>
-                </a:solidFill>
-                <a:latin typeface="Calibri" pitchFamily="34" charset="0"/>
-                <a:ea typeface="Calibri" pitchFamily="34" charset="-122"/>
-                <a:cs typeface="Calibri" pitchFamily="34" charset="-120"/>
-              </a:rPr>
-              <a:t>Q: “From what date should maintenance be paid?”</a:t>
-            </a:r>
-            <a:endParaRPr lang="en-US" sz="1000" dirty="0"/>
-          </a:p>
-        </p:txBody>
-      </p:sp>
-      <p:sp>
-        <p:nvSpPr>
-          <p:cNvPr id="25" name="Shape 19"/>
-          <p:cNvSpPr/>
-          <p:nvPr/>
-        </p:nvSpPr>
-        <p:spPr>
-          <a:xfrm>
-            <a:off x="6515100" y="4023360"/>
-            <a:ext cx="3520440" cy="1965960"/>
-          </a:xfrm>
-          <a:prstGeom prst="roundRect">
-            <a:avLst>
-              <a:gd name="adj" fmla="val 3721"/>
-            </a:avLst>
-          </a:prstGeom>
-          <a:solidFill>
-            <a:srgbClr val="FFFFFF"/>
-          </a:solidFill>
-          <a:ln w="15875">
-            <a:solidFill>
-              <a:srgbClr val="4C6A8A"/>
-            </a:solidFill>
-            <a:prstDash val="dash"/>
-          </a:ln>
-        </p:spPr>
-      </p:sp>
-      <p:sp>
-        <p:nvSpPr>
-          <p:cNvPr id="26" name="Shape 20"/>
-          <p:cNvSpPr/>
-          <p:nvPr/>
-        </p:nvSpPr>
-        <p:spPr>
-          <a:xfrm>
-            <a:off x="8001000" y="4343400"/>
-            <a:ext cx="548640" cy="548640"/>
-          </a:xfrm>
-          <a:prstGeom prst="ellipse">
-            <a:avLst/>
-          </a:prstGeom>
-          <a:solidFill>
-            <a:srgbClr val="E4E9F1"/>
-          </a:solidFill>
-          <a:ln/>
-        </p:spPr>
-      </p:sp>
-      <p:pic>
-        <p:nvPicPr>
-          <p:cNvPr id="27" name="Image 4" descr="/home/claude/legalrag_ppt/icons/file.png"/>
-          <p:cNvPicPr>
-            <a:picLocks noChangeAspect="1"/>
-          </p:cNvPicPr>
-          <p:nvPr/>
-        </p:nvPicPr>
-        <p:blipFill>
-          <a:blip r:embed="rId3"/>
-          <a:stretch>
-            <a:fillRect/>
-          </a:stretch>
-        </p:blipFill>
-        <p:spPr>
-          <a:xfrm>
-            <a:off x="8072323" y="4414723"/>
-            <a:ext cx="405994" cy="405994"/>
-          </a:xfrm>
-          <a:prstGeom prst="rect">
-            <a:avLst/>
-          </a:prstGeom>
-        </p:spPr>
-      </p:pic>
-      <p:sp>
-        <p:nvSpPr>
-          <p:cNvPr id="28" name="Text 21"/>
-          <p:cNvSpPr/>
-          <p:nvPr/>
-        </p:nvSpPr>
-        <p:spPr>
-          <a:xfrm>
-            <a:off x="6652260" y="5029200"/>
-            <a:ext cx="3246120" cy="256032"/>
-          </a:xfrm>
-          <a:prstGeom prst="rect">
-            <a:avLst/>
-          </a:prstGeom>
-          <a:noFill/>
-          <a:ln/>
-        </p:spPr>
-        <p:txBody>
-          <a:bodyPr wrap="square" lIns="0" tIns="0" rIns="0" bIns="0" rtlCol="0" anchor="ctr"/>
-          <a:lstStyle/>
-          <a:p>
-            <a:pPr marL="0" indent="0" algn="ctr">
-              <a:buNone/>
-            </a:pPr>
-            <a:r>
-              <a:rPr lang="en-US" sz="1150" b="1" dirty="0">
-                <a:solidFill>
-                  <a:srgbClr val="4C6A8A"/>
-                </a:solidFill>
-                <a:latin typeface="Calibri" pitchFamily="34" charset="0"/>
-                <a:ea typeface="Calibri" pitchFamily="34" charset="-122"/>
-                <a:cs typeface="Calibri" pitchFamily="34" charset="-120"/>
-              </a:rPr>
-              <a:t>Screenshot 5</a:t>
-            </a:r>
-            <a:endParaRPr lang="en-US" sz="1150" dirty="0"/>
-          </a:p>
-        </p:txBody>
-      </p:sp>
-      <p:sp>
-        <p:nvSpPr>
-          <p:cNvPr id="29" name="Text 22"/>
-          <p:cNvSpPr/>
-          <p:nvPr/>
-        </p:nvSpPr>
-        <p:spPr>
-          <a:xfrm>
-            <a:off x="6697980" y="5303520"/>
-            <a:ext cx="3154680" cy="594360"/>
-          </a:xfrm>
-          <a:prstGeom prst="rect">
-            <a:avLst/>
-          </a:prstGeom>
-          <a:noFill/>
-          <a:ln/>
-        </p:spPr>
-        <p:txBody>
-          <a:bodyPr wrap="square" lIns="0" tIns="0" rIns="0" bIns="0" rtlCol="0" anchor="t"/>
-          <a:lstStyle/>
-          <a:p>
-            <a:pPr marL="0" indent="0" algn="ctr">
-              <a:buNone/>
-            </a:pPr>
-            <a:r>
-              <a:rPr lang="en-US" sz="1000" dirty="0">
-                <a:solidFill>
-                  <a:srgbClr val="5B6B7F"/>
-                </a:solidFill>
-                <a:latin typeface="Calibri" pitchFamily="34" charset="0"/>
-                <a:ea typeface="Calibri" pitchFamily="34" charset="-122"/>
-                <a:cs typeface="Calibri" pitchFamily="34" charset="-120"/>
-              </a:rPr>
-              <a:t>Sidebar showing indexed documents</a:t>
-            </a:r>
-            <a:endParaRPr lang="en-US" sz="1000" dirty="0"/>
-          </a:p>
-        </p:txBody>
-      </p:sp>
-      <p:sp>
-        <p:nvSpPr>
-          <p:cNvPr id="30" name="Text 23"/>
-          <p:cNvSpPr/>
-          <p:nvPr/>
-        </p:nvSpPr>
-        <p:spPr>
-          <a:xfrm>
-            <a:off x="457200" y="6473952"/>
-            <a:ext cx="7315200" cy="274320"/>
-          </a:xfrm>
-          <a:prstGeom prst="rect">
-            <a:avLst/>
-          </a:prstGeom>
-          <a:noFill/>
-          <a:ln/>
-        </p:spPr>
-        <p:txBody>
-          <a:bodyPr wrap="square" rtlCol="0" anchor="ctr"/>
-          <a:lstStyle/>
-          <a:p>
-            <a:pPr marL="0" indent="0" algn="l">
-              <a:buNone/>
-            </a:pPr>
-            <a:r>
-              <a:rPr lang="en-US" sz="900" dirty="0">
-                <a:solidFill>
-                  <a:srgbClr val="5B6B7F"/>
-                </a:solidFill>
-                <a:latin typeface="Calibri" pitchFamily="34" charset="0"/>
-                <a:ea typeface="Calibri" pitchFamily="34" charset="-122"/>
-                <a:cs typeface="Calibri" pitchFamily="34" charset="-120"/>
-              </a:rPr>
-              <a:t>LegalRAG  ·  22AIE305 Introduction to Cloud Computing</a:t>
-            </a:r>
-            <a:endParaRPr lang="en-US" sz="900" dirty="0"/>
-          </a:p>
-        </p:txBody>
-      </p:sp>
-      <p:sp>
-        <p:nvSpPr>
-          <p:cNvPr id="31" name="Text 24"/>
-          <p:cNvSpPr/>
-          <p:nvPr/>
-        </p:nvSpPr>
-        <p:spPr>
-          <a:xfrm>
-            <a:off x="11274552" y="6473952"/>
-            <a:ext cx="457200" cy="274320"/>
-          </a:xfrm>
-          <a:prstGeom prst="rect">
-            <a:avLst/>
-          </a:prstGeom>
-          <a:noFill/>
-          <a:ln/>
-        </p:spPr>
-        <p:txBody>
-          <a:bodyPr wrap="square" rtlCol="0" anchor="ctr"/>
-          <a:lstStyle/>
-          <a:p>
-            <a:pPr marL="0" indent="0" algn="r">
-              <a:buNone/>
-            </a:pPr>
-            <a:r>
-              <a:rPr lang="en-US" sz="900" dirty="0">
-                <a:solidFill>
-                  <a:srgbClr val="5B6B7F"/>
-                </a:solidFill>
-                <a:latin typeface="Calibri" pitchFamily="34" charset="0"/>
-                <a:ea typeface="Calibri" pitchFamily="34" charset="-122"/>
-                <a:cs typeface="Calibri" pitchFamily="34" charset="-120"/>
-              </a:rPr>
-              <a:t>14</a:t>
-            </a:r>
-            <a:endParaRPr lang="en-US" sz="900" dirty="0"/>
-          </a:p>
-        </p:txBody>
-      </p:sp>
-    </p:spTree>
-  </p:cSld>
-  <p:clrMapOvr>
-    <a:masterClrMapping/>
-  </p:clrMapOvr>
-</p:sld>
-</file>
-
-<file path=ppt/slides/slide15.xml><?xml version="1.0" encoding="utf-8"?>
-<p:sld xmlns:a="http://schemas.openxmlformats.org/drawingml/2006/main" xmlns:r="http://schemas.openxmlformats.org/officeDocument/2006/relationships" xmlns:p="http://schemas.openxmlformats.org/presentationml/2006/main">
   <p:cSld name="Slide 16">
     <p:bg>
       <p:bgPr>
@@ -10974,7 +9916,7 @@
 </p:sld>
 </file>
 
-<file path=ppt/slides/slide16.xml><?xml version="1.0" encoding="utf-8"?>
+<file path=ppt/slides/slide15.xml><?xml version="1.0" encoding="utf-8"?>
 <p:sld xmlns:a="http://schemas.openxmlformats.org/drawingml/2006/main" xmlns:r="http://schemas.openxmlformats.org/officeDocument/2006/relationships" xmlns:p="http://schemas.openxmlformats.org/presentationml/2006/main">
   <p:cSld name="Slide 17">
     <p:bg>
@@ -11847,7 +10789,7 @@
 </p:sld>
 </file>
 
-<file path=ppt/slides/slide17.xml><?xml version="1.0" encoding="utf-8"?>
+<file path=ppt/slides/slide16.xml><?xml version="1.0" encoding="utf-8"?>
 <p:sld xmlns:a="http://schemas.openxmlformats.org/drawingml/2006/main" xmlns:r="http://schemas.openxmlformats.org/officeDocument/2006/relationships" xmlns:p="http://schemas.openxmlformats.org/presentationml/2006/main">
   <p:cSld name="Slide 18">
     <p:bg>
@@ -11980,6 +10922,30 @@
               <a:buNone/>
             </a:pPr>
             <a:r>
+              <a:rPr lang="en-US" sz="1500" i="1" dirty="0" err="1">
+                <a:solidFill>
+                  <a:srgbClr val="C7D2E3"/>
+                </a:solidFill>
+                <a:latin typeface="Calibri" pitchFamily="34" charset="0"/>
+                <a:ea typeface="Calibri" pitchFamily="34" charset="-122"/>
+                <a:cs typeface="Calibri" pitchFamily="34" charset="-120"/>
+              </a:rPr>
+              <a:t>Juriscope</a:t>
+            </a:r>
+            <a:endParaRPr lang="en-US" sz="1500" i="1" dirty="0">
+              <a:solidFill>
+                <a:srgbClr val="C7D2E3"/>
+              </a:solidFill>
+              <a:latin typeface="Calibri" pitchFamily="34" charset="0"/>
+              <a:ea typeface="Calibri" pitchFamily="34" charset="-122"/>
+              <a:cs typeface="Calibri" pitchFamily="34" charset="-120"/>
+            </a:endParaRPr>
+          </a:p>
+          <a:p>
+            <a:pPr marL="0" indent="0" algn="ctr">
+              <a:buNone/>
+            </a:pPr>
+            <a:r>
               <a:rPr lang="en-US" sz="1500" i="1" dirty="0">
                 <a:solidFill>
                   <a:srgbClr val="C7D2E3"/>
@@ -11988,7 +10954,7 @@
                 <a:ea typeface="Calibri" pitchFamily="34" charset="-122"/>
                 <a:cs typeface="Calibri" pitchFamily="34" charset="-120"/>
               </a:rPr>
-              <a:t>LegalRAG — Making legal knowledge accessible through cloud-native AI</a:t>
+              <a:t> — Making legal knowledge accessible through cloud-native AI</a:t>
             </a:r>
             <a:endParaRPr lang="en-US" sz="1500" dirty="0"/>
           </a:p>

</xml_diff>